<commit_message>
Add Brief Communication manuscript with Japan contamination analysis
- Fix circular distance bug in peak comparison (Devin Review)
- Rename 'April-start' to 'Mar/Apr-start' (Korea is March, not April)
- Add manuscript docx: IMRaD format with natural experiment + sensitivity
  analysis showing Japan fiscal year-end drives the March peak
- Include Table 1 (group statistics) and Table 2 (sensitivity: excluding
  Japan eliminates significance in country-known subset, p=0.13)
- Updated PPTX with corrected figure

Co-Authored-By: Tatsuki Onishi <bougtoir@gmail.com>
</commit_message>
<xml_diff>
--- a/stem_cell_seasonality/output/Natural_Experiment_Figure.pptx
+++ b/stem_cell_seasonality/output/Natural_Experiment_Figure.pptx
@@ -3112,7 +3112,7 @@
           <a:p>
             <a:r>
               <a:rPr sz="1600" b="1"/>
-              <a:t>Figure 3. Natural Experiment: Academic Calendar vs Biological Seasonality</a:t>
+              <a:t>Figure 1. Natural Experiment: Academic Calendar vs Biological Seasonality</a:t>
             </a:r>
           </a:p>
         </p:txBody>
@@ -3165,7 +3165,7 @@
           <a:p>
             <a:r>
               <a:rPr sz="1000"/>
-              <a:t>Geographic variation in academic year start months used as instrument. Japan/Korea (April, n=250), USA/EU/CN (Sep/Oct, n=2825), Australia/NZ/BR (Jan/Feb, SH, n=83). Japan shows significant March peak (p=0.0006); USA/EU shows no significant seasonality.</a:t>
+              <a:t>Geographic variation in academic year start months used as natural experiment. Japan/Korea (Mar/Apr, n=250): significant March peak (p=0.0006). USA/EU/CN (Sep/Oct, n=2,825): no significant seasonality. Sensitivity: removing Japan eliminates March peak from full dataset.</a:t>
             </a:r>
           </a:p>
         </p:txBody>

</xml_diff>